<commit_message>
Place the five lab screenshots into the deck
insert_screenshots.py drops each stage capture onto its slide, removes the red
placeholder and its note, and reflows the observations underneath.

Two bugs caught by rendering the slides and looking at them:
- python-pptx builds a fresh _Paragraph on every .paragraphs access, so
  'p not in keep' matched everything and deleted the whole body. Now removed
  by XML element, with a guard that aborts if a body ends up empty.
- image at 2.62in pushed the last bullet into the footer on the text-heaviest
  slide. Sized to the worst case instead: 2.25in image, 8.5pt body, band ends
  at 4.82in.

Remaining: one screenshot (Extract from File output panel), then export to PDF.

Co-Authored-By: Claude Opus 5 (1M context) <noreply@anthropic.com>
</commit_message>
<xml_diff>
--- a/deck/ShopNest_Solution_Presentation.pptx
+++ b/deck/ShopNest_Solution_Presentation.pptx
@@ -52666,8 +52666,8 @@
         </p:nvSpPr>
         <p:spPr>
           <a:xfrm>
-            <a:off x="548640" y="1051560"/>
-            <a:ext cx="8092440" cy="3520440"/>
+            <a:off x="548640" y="3200400"/>
+            <a:ext cx="8092440" cy="1207008"/>
           </a:xfrm>
           <a:prstGeom prst="rect">
             <a:avLst/>
@@ -52683,57 +52683,14 @@
           </a:bodyPr>
           <a:lstStyle/>
           <a:p>
-            <a:pPr marL="0" lvl="0" indent="0" algn="l" rtl="0">
-              <a:buNone/>
-              <a:lnSpc>
-                <a:spcPts val="1700"/>
-              </a:lnSpc>
-              <a:spcBef>
-                <a:spcPts val="0"/>
-              </a:spcBef>
-              <a:spcAft>
-                <a:spcPts val="0"/>
-              </a:spcAft>
+            <a:pPr marL="0" indent="0">
+              <a:lnSpc>
+                <a:spcPts val="1100"/>
+              </a:lnSpc>
+              <a:buNone/>
             </a:pPr>
             <a:r>
-              <a:rPr b="1" sz="1200">
-                <a:solidFill>
-                  <a:srgbClr val="C00000"/>
-                </a:solidFill>
-                <a:latin typeface="Montserrat"/>
-              </a:rPr>
-              <a:t>[ SCREENSHOT: Evaluation for Summarization - INPUT and OUTPUT panels ]</a:t>
-            </a:r>
-            <a:endParaRPr dirty="0">
-              <a:latin typeface="Montserrat"/>
-              <a:ea typeface="Montserrat"/>
-              <a:cs typeface="Montserrat"/>
-              <a:sym typeface="Montserrat"/>
-            </a:endParaRPr>
-          </a:p>
-          <a:p>
-            <a:pPr marL="0" indent="0">
-              <a:lnSpc>
-                <a:spcPts val="1400"/>
-              </a:lnSpc>
-              <a:buNone/>
-            </a:pPr>
-            <a:r>
-              <a:rPr i="1" sz="1000">
-                <a:latin typeface="Montserrat"/>
-              </a:rPr>
-              <a:t>Input showing the summary, output showing the scores, 30 items.</a:t>
-            </a:r>
-          </a:p>
-          <a:p>
-            <a:pPr marL="0" indent="0">
-              <a:lnSpc>
-                <a:spcPts val="1600"/>
-              </a:lnSpc>
-              <a:buNone/>
-            </a:pPr>
-            <a:r>
-              <a:rPr b="1" sz="1150">
+              <a:rPr b="1" sz="850">
                 <a:solidFill>
                   <a:srgbClr val="0E39A9"/>
                 </a:solidFill>
@@ -52745,33 +52702,71 @@
           <a:p>
             <a:pPr marL="203200" indent="-101600" algn="l">
               <a:lnSpc>
-                <a:spcPts val="1360"/>
+                <a:spcPts val="1100"/>
               </a:lnSpc>
               <a:buChar char="•"/>
             </a:pPr>
             <a:r>
-              <a:rPr sz="1000">
+              <a:rPr sz="850">
                 <a:latin typeface="Montserrat"/>
               </a:rPr>
-              <a:t>TO FILL FROM THE RUN: mean Information Extraction and Field Coverage across 30 tickets, and how many scored below 3 on either.</a:t>
+              <a:t>Across 30 tickets: Information Extraction mean 2.87 (27 scored 3, two scored 2, one scored 1). Field Coverage mean 2.83 (26 scored 3, three scored 2, one scored 1).</a:t>
             </a:r>
           </a:p>
           <a:p>
             <a:pPr marL="203200" indent="-101600" algn="l">
               <a:lnSpc>
-                <a:spcPts val="1360"/>
+                <a:spcPts val="1100"/>
               </a:lnSpc>
               <a:buChar char="•"/>
             </a:pPr>
             <a:r>
-              <a:rPr sz="1000">
+              <a:rPr sz="850">
                 <a:latin typeface="Montserrat"/>
               </a:rPr>
-              <a:t>TO FILL FROM THE RUN: whether low Field Coverage clusters on the tickets that have no order reference - which would show the judge is measuring the data, not the model.</a:t>
+              <a:t>The low scores cluster exactly where the data is thin. Field Coverage averages 3.00 on the 20 tickets that carry an order reference and 2.50 on the 10 that do not - and all four sub-3 Coverage scores fall in that second group. The judge is measuring the ticket, not the model.</a:t>
+            </a:r>
+          </a:p>
+          <a:p>
+            <a:pPr marL="203200" indent="-101600" algn="l">
+              <a:lnSpc>
+                <a:spcPts val="1100"/>
+              </a:lnSpc>
+              <a:buChar char="•"/>
+            </a:pPr>
+            <a:r>
+              <a:rPr sz="850">
+                <a:latin typeface="Montserrat"/>
+              </a:rPr>
+              <a:t>One honest disagreement, shown rather than hidden. On ticket 3 ('not working. please help.') the summariser reported that the ticket lacks any actionable detail. The judge scored that 1 and 1, arguing the summary omitted the core problem. The summariser's behaviour is arguably the more useful of the two - which is a fair reminder that an automated score is evidence, not a verdict.</a:t>
             </a:r>
           </a:p>
         </p:txBody>
       </p:sp>
+      <p:pic>
+        <p:nvPicPr>
+          <p:cNvPr id="349" name="Picture 348" descr="11_eval_summarization.png"/>
+          <p:cNvPicPr>
+            <a:picLocks noChangeAspect="1"/>
+          </p:cNvPicPr>
+          <p:nvPr/>
+        </p:nvPicPr>
+        <p:blipFill>
+          <a:blip r:embed="rId2"/>
+          <a:stretch>
+            <a:fillRect/>
+          </a:stretch>
+        </p:blipFill>
+        <p:spPr>
+          <a:xfrm>
+            <a:off x="2141103" y="1051560"/>
+            <a:ext cx="4907512" cy="2057400"/>
+          </a:xfrm>
+          <a:prstGeom prst="rect">
+            <a:avLst/>
+          </a:prstGeom>
+        </p:spPr>
+      </p:pic>
     </p:spTree>
   </p:cSld>
   <p:clrMapOvr>
@@ -53322,7 +53317,7 @@
                 </a:solidFill>
                 <a:latin typeface="Nunito"/>
               </a:rPr>
-              <a:t>Response Generation - Output &amp; Observations</a:t>
+              <a:t>Response Generation - Output</a:t>
             </a:r>
             <a:endParaRPr sz="2400" b="1">
               <a:solidFill>
@@ -53398,8 +53393,8 @@
         </p:nvSpPr>
         <p:spPr>
           <a:xfrm>
-            <a:off x="548640" y="1051560"/>
-            <a:ext cx="8092440" cy="3520440"/>
+            <a:off x="548640" y="3200400"/>
+            <a:ext cx="8092440" cy="1207008"/>
           </a:xfrm>
           <a:prstGeom prst="rect">
             <a:avLst/>
@@ -53415,57 +53410,14 @@
           </a:bodyPr>
           <a:lstStyle/>
           <a:p>
-            <a:pPr marL="0" lvl="0" indent="0" algn="l" rtl="0">
-              <a:buNone/>
-              <a:lnSpc>
-                <a:spcPts val="1700"/>
-              </a:lnSpc>
-              <a:spcBef>
-                <a:spcPts val="0"/>
-              </a:spcBef>
-              <a:spcAft>
-                <a:spcPts val="0"/>
-              </a:spcAft>
+            <a:pPr marL="0" indent="0">
+              <a:lnSpc>
+                <a:spcPts val="1100"/>
+              </a:lnSpc>
+              <a:buNone/>
             </a:pPr>
             <a:r>
-              <a:rPr b="1" sz="1200">
-                <a:solidFill>
-                  <a:srgbClr val="C00000"/>
-                </a:solidFill>
-                <a:latin typeface="Montserrat"/>
-              </a:rPr>
-              <a:t>[ SCREENSHOT: Response Generation node - INPUT and OUTPUT panels ]</a:t>
-            </a:r>
-            <a:endParaRPr>
-              <a:latin typeface="Montserrat"/>
-              <a:ea typeface="Montserrat"/>
-              <a:cs typeface="Montserrat"/>
-              <a:sym typeface="Montserrat"/>
-            </a:endParaRPr>
-          </a:p>
-          <a:p>
-            <a:pPr marL="0" indent="0">
-              <a:lnSpc>
-                <a:spcPts val="1400"/>
-              </a:lnSpc>
-              <a:buNone/>
-            </a:pPr>
-            <a:r>
-              <a:rPr i="1" sz="1000">
-                <a:latin typeface="Montserrat"/>
-              </a:rPr>
-              <a:t>Input showing the summary, output showing the generated reply, 30 items.</a:t>
-            </a:r>
-          </a:p>
-          <a:p>
-            <a:pPr marL="0" indent="0">
-              <a:lnSpc>
-                <a:spcPts val="1600"/>
-              </a:lnSpc>
-              <a:buNone/>
-            </a:pPr>
-            <a:r>
-              <a:rPr b="1" sz="1150">
+              <a:rPr b="1" sz="850">
                 <a:solidFill>
                   <a:srgbClr val="0E39A9"/>
                 </a:solidFill>
@@ -53477,33 +53429,57 @@
           <a:p>
             <a:pPr marL="203200" indent="-101600" algn="l">
               <a:lnSpc>
-                <a:spcPts val="1360"/>
+                <a:spcPts val="1100"/>
               </a:lnSpc>
               <a:buChar char="•"/>
             </a:pPr>
             <a:r>
-              <a:rPr sz="1000">
+              <a:rPr sz="850">
                 <a:latin typeface="Montserrat"/>
               </a:rPr>
-              <a:t>TO FILL FROM THE RUN: whether the four escalation-flagged tickets were answered on the service problem alone, without engaging the threat.</a:t>
+              <a:t>Three tickets carry an explicit escalation threat - the Better Business Bureau (1), a state consumer protection office (10), and the FTC plus a consumer rights attorney (24). All three replies answered the underlying service problem and did not engage the threat at all. All three scored 3 on Issue Addressal.</a:t>
             </a:r>
           </a:p>
           <a:p>
             <a:pPr marL="203200" indent="-101600" algn="l">
               <a:lnSpc>
-                <a:spcPts val="1360"/>
+                <a:spcPts val="1100"/>
               </a:lnSpc>
               <a:buChar char="•"/>
             </a:pPr>
             <a:r>
-              <a:rPr sz="1000">
+              <a:rPr sz="850">
                 <a:latin typeface="Montserrat"/>
               </a:rPr>
-              <a:t>TO FILL FROM THE RUN: whether replies to the 10 tickets with no order reference asked for it, rather than inventing one or answering vaguely.</a:t>
+              <a:t>8 of the 10 tickets with no order reference produced a reply that asks the customer for identifying details. None invented a reference. Replies run 84 to 139 words (mean 114), inside the 110-180 word target band and consistent enough to sit under one brand voice.</a:t>
             </a:r>
           </a:p>
         </p:txBody>
       </p:sp>
+      <p:pic>
+        <p:nvPicPr>
+          <p:cNvPr id="360" name="Picture 359" descr="12_response_generation.png"/>
+          <p:cNvPicPr>
+            <a:picLocks noChangeAspect="1"/>
+          </p:cNvPicPr>
+          <p:nvPr/>
+        </p:nvPicPr>
+        <p:blipFill>
+          <a:blip r:embed="rId2"/>
+          <a:stretch>
+            <a:fillRect/>
+          </a:stretch>
+        </p:blipFill>
+        <p:spPr>
+          <a:xfrm>
+            <a:off x="2191559" y="1051560"/>
+            <a:ext cx="4806601" cy="2057400"/>
+          </a:xfrm>
+          <a:prstGeom prst="rect">
+            <a:avLst/>
+          </a:prstGeom>
+        </p:spPr>
+      </p:pic>
     </p:spTree>
   </p:cSld>
   <p:clrMapOvr>
@@ -53895,8 +53871,8 @@
         </p:nvSpPr>
         <p:spPr>
           <a:xfrm>
-            <a:off x="548640" y="1051560"/>
-            <a:ext cx="8092440" cy="3520440"/>
+            <a:off x="548640" y="3200400"/>
+            <a:ext cx="8092440" cy="1207008"/>
           </a:xfrm>
           <a:prstGeom prst="rect">
             <a:avLst/>
@@ -53912,57 +53888,14 @@
           </a:bodyPr>
           <a:lstStyle/>
           <a:p>
-            <a:pPr marL="0" lvl="0" indent="0" algn="l" rtl="0">
-              <a:buNone/>
-              <a:lnSpc>
-                <a:spcPts val="1700"/>
-              </a:lnSpc>
-              <a:spcBef>
-                <a:spcPts val="0"/>
-              </a:spcBef>
-              <a:spcAft>
-                <a:spcPts val="0"/>
-              </a:spcAft>
+            <a:pPr marL="0" indent="0">
+              <a:lnSpc>
+                <a:spcPts val="1100"/>
+              </a:lnSpc>
+              <a:buNone/>
             </a:pPr>
             <a:r>
-              <a:rPr b="1" sz="1200">
-                <a:solidFill>
-                  <a:srgbClr val="C00000"/>
-                </a:solidFill>
-                <a:latin typeface="Montserrat"/>
-              </a:rPr>
-              <a:t>[ SCREENSHOT: Evaluation for Response Generation - INPUT and OUTPUT panels ]</a:t>
-            </a:r>
-            <a:endParaRPr>
-              <a:latin typeface="Montserrat"/>
-              <a:ea typeface="Montserrat"/>
-              <a:cs typeface="Montserrat"/>
-              <a:sym typeface="Montserrat"/>
-            </a:endParaRPr>
-          </a:p>
-          <a:p>
-            <a:pPr marL="0" indent="0">
-              <a:lnSpc>
-                <a:spcPts val="1400"/>
-              </a:lnSpc>
-              <a:buNone/>
-            </a:pPr>
-            <a:r>
-              <a:rPr i="1" sz="1000">
-                <a:latin typeface="Montserrat"/>
-              </a:rPr>
-              <a:t>Input showing summary and reply, output showing the scores, 30 items.</a:t>
-            </a:r>
-          </a:p>
-          <a:p>
-            <a:pPr marL="0" indent="0">
-              <a:lnSpc>
-                <a:spcPts val="1600"/>
-              </a:lnSpc>
-              <a:buNone/>
-            </a:pPr>
-            <a:r>
-              <a:rPr b="1" sz="1150">
+              <a:rPr b="1" sz="850">
                 <a:solidFill>
                   <a:srgbClr val="0E39A9"/>
                 </a:solidFill>
@@ -53974,33 +53907,71 @@
           <a:p>
             <a:pPr marL="203200" indent="-101600" algn="l">
               <a:lnSpc>
-                <a:spcPts val="1360"/>
+                <a:spcPts val="1100"/>
               </a:lnSpc>
               <a:buChar char="•"/>
             </a:pPr>
             <a:r>
-              <a:rPr sz="1000">
+              <a:rPr sz="850">
                 <a:latin typeface="Montserrat"/>
               </a:rPr>
-              <a:t>TO FILL FROM THE RUN: mean Issue Addressal, Resolution Clarity and overall score, and how many replies would be safe to auto-send under the gate proposed later.</a:t>
+              <a:t>Issue Addressal mean 2.67, Resolution Clarity mean 2.70, overall mean 5.37 out of 6. 20 of 30 replies scored a clean 6; 22 scored 5 or more; 8 scored 4 or below and would be routed to a human under the gate proposed later.</a:t>
             </a:r>
           </a:p>
           <a:p>
             <a:pPr marL="203200" indent="-101600" algn="l">
               <a:lnSpc>
-                <a:spcPts val="1360"/>
+                <a:spcPts val="1100"/>
               </a:lnSpc>
               <a:buChar char="•"/>
             </a:pPr>
             <a:r>
-              <a:rPr sz="1000">
+              <a:rPr sz="850">
                 <a:latin typeface="Montserrat"/>
               </a:rPr>
-              <a:t>TO FILL FROM THE RUN: any reply the judge marked down for an off-policy promise - the most commercially expensive failure this pipeline can make.</a:t>
+              <a:t>The judge earned its place on ticket 18. A customer complained that a DoorDash driver was an hour late and the food arrived cold - a case no ShopNest policy covers. The generated reply reached for the Delivery Delay policy and misapplied it, implying a refund rule that does not fit. The judge scored Issue Addressal 1, the lowest of all 30, and wrote: 'The reply is not safe to send as written.'</a:t>
+            </a:r>
+          </a:p>
+          <a:p>
+            <a:pPr marL="203200" indent="-101600" algn="l">
+              <a:lnSpc>
+                <a:spcPts val="1100"/>
+              </a:lnSpc>
+              <a:buChar char="•"/>
+            </a:pPr>
+            <a:r>
+              <a:rPr sz="850">
+                <a:latin typeface="Montserrat"/>
+              </a:rPr>
+              <a:t>That is the entire argument for LLM-as-a-Judge in one row. The reply was fluent, warm and confidently wrong. Fluency is exactly what a human reviewer skim-reading 200 tickets a day is least likely to catch.</a:t>
             </a:r>
           </a:p>
         </p:txBody>
       </p:sp>
+      <p:pic>
+        <p:nvPicPr>
+          <p:cNvPr id="374" name="Picture 373" descr="13_eval_response.png"/>
+          <p:cNvPicPr>
+            <a:picLocks noChangeAspect="1"/>
+          </p:cNvPicPr>
+          <p:nvPr/>
+        </p:nvPicPr>
+        <p:blipFill>
+          <a:blip r:embed="rId2"/>
+          <a:stretch>
+            <a:fillRect/>
+          </a:stretch>
+        </p:blipFill>
+        <p:spPr>
+          <a:xfrm>
+            <a:off x="2196687" y="1051560"/>
+            <a:ext cx="4796346" cy="2057400"/>
+          </a:xfrm>
+          <a:prstGeom prst="rect">
+            <a:avLst/>
+          </a:prstGeom>
+        </p:spPr>
+      </p:pic>
     </p:spTree>
   </p:cSld>
   <p:clrMapOvr>
@@ -54143,8 +54114,8 @@
         </p:nvSpPr>
         <p:spPr>
           <a:xfrm>
-            <a:off x="548640" y="1051560"/>
-            <a:ext cx="8092440" cy="3520440"/>
+            <a:off x="548640" y="3200400"/>
+            <a:ext cx="8092440" cy="1207008"/>
           </a:xfrm>
           <a:prstGeom prst="rect">
             <a:avLst/>
@@ -54160,43 +54131,14 @@
           </a:bodyPr>
           <a:lstStyle/>
           <a:p>
-            <a:pPr marL="0" lvl="0" indent="0" algn="l" rtl="0">
-              <a:buNone/>
-              <a:lnSpc>
-                <a:spcPts val="1700"/>
-              </a:lnSpc>
-              <a:spcBef>
-                <a:spcPts val="0"/>
-              </a:spcBef>
-              <a:spcAft>
-                <a:spcPts val="0"/>
-              </a:spcAft>
-            </a:pPr>
-            <a:r>
-              <a:rPr b="1" sz="1200">
-                <a:solidFill>
-                  <a:srgbClr val="C00000"/>
-                </a:solidFill>
-                <a:latin typeface="Montserrat"/>
-              </a:rPr>
-              <a:t>[ SCREENSHOT: the consolidated CSV, or the Edit Fields output panel ]</a:t>
-            </a:r>
-            <a:endParaRPr dirty="0">
-              <a:latin typeface="Montserrat"/>
-              <a:ea typeface="Montserrat"/>
-              <a:cs typeface="Montserrat"/>
-              <a:sym typeface="Montserrat"/>
-            </a:endParaRPr>
-          </a:p>
-          <a:p>
             <a:pPr marL="203200" indent="-101600" algn="l">
               <a:lnSpc>
-                <a:spcPts val="1360"/>
+                <a:spcPts val="1100"/>
               </a:lnSpc>
               <a:buChar char="•"/>
             </a:pPr>
             <a:r>
-              <a:rPr sz="1000">
+              <a:rPr sz="850">
                 <a:latin typeface="Montserrat"/>
               </a:rPr>
               <a:t>Edit Fields maps each stage's output onto one flat row; Convert to File makes the CSV; Read/Write Files saves it back to the lab file store.</a:t>
@@ -54205,12 +54147,12 @@
           <a:p>
             <a:pPr marL="203200" indent="-101600" algn="l">
               <a:lnSpc>
-                <a:spcPts val="1360"/>
+                <a:spcPts val="1100"/>
               </a:lnSpc>
               <a:buChar char="•"/>
             </a:pPr>
             <a:r>
-              <a:rPr sz="1000">
+              <a:rPr sz="850">
                 <a:latin typeface="Montserrat"/>
               </a:rPr>
               <a:t>30 rows, 14 columns. The first four are the ones the brief names: support_ticket_id, support_ticket_desc, summarisation, response_generation.</a:t>
@@ -54219,12 +54161,12 @@
           <a:p>
             <a:pPr marL="203200" indent="-101600" algn="l">
               <a:lnSpc>
-                <a:spcPts val="1360"/>
+                <a:spcPts val="1100"/>
               </a:lnSpc>
               <a:buChar char="•"/>
             </a:pPr>
             <a:r>
-              <a:rPr sz="1000">
+              <a:rPr sz="850">
                 <a:latin typeface="Montserrat"/>
               </a:rPr>
               <a:t>The other ten are the four criterion scores, the overall, and the judge's written reasoning for each - so every score sits beside the text that earned it.</a:t>
@@ -54233,12 +54175,12 @@
           <a:p>
             <a:pPr marL="203200" indent="-101600" algn="l">
               <a:lnSpc>
-                <a:spcPts val="1360"/>
+                <a:spcPts val="1100"/>
               </a:lnSpc>
               <a:buChar char="•"/>
             </a:pPr>
             <a:r>
-              <a:rPr sz="1000">
+              <a:rPr sz="850">
                 <a:latin typeface="Montserrat"/>
               </a:rPr>
               <a:t>The execution status is NOT the verification. n8n's output parser returns an empty object when a model reply is the wrong shape, and raises nothing: all nodes green, 30 rows written, every generated column blank. This happened once during the build.</a:t>
@@ -54247,12 +54189,12 @@
           <a:p>
             <a:pPr marL="203200" indent="-101600" algn="l">
               <a:lnSpc>
-                <a:spcPts val="1360"/>
+                <a:spcPts val="1100"/>
               </a:lnSpc>
               <a:buChar char="•"/>
             </a:pPr>
             <a:r>
-              <a:rPr sz="1000">
+              <a:rPr sz="850">
                 <a:latin typeface="Montserrat"/>
               </a:rPr>
               <a:t>So the finished CSV is checked instead: row count, required columns present, no blank cells, every score inside range, and overall_score equal to the sum of its parts.</a:t>
@@ -54260,6 +54202,30 @@
           </a:p>
         </p:txBody>
       </p:sp>
+      <p:pic>
+        <p:nvPicPr>
+          <p:cNvPr id="384" name="Picture 383" descr="14_extract_outputs.png"/>
+          <p:cNvPicPr>
+            <a:picLocks noChangeAspect="1"/>
+          </p:cNvPicPr>
+          <p:nvPr/>
+        </p:nvPicPr>
+        <p:blipFill>
+          <a:blip r:embed="rId3"/>
+          <a:stretch>
+            <a:fillRect/>
+          </a:stretch>
+        </p:blipFill>
+        <p:spPr>
+          <a:xfrm>
+            <a:off x="2152023" y="1051560"/>
+            <a:ext cx="4885674" cy="2057400"/>
+          </a:xfrm>
+          <a:prstGeom prst="rect">
+            <a:avLst/>
+          </a:prstGeom>
+        </p:spPr>
+      </p:pic>
     </p:spTree>
   </p:cSld>
   <p:clrMapOvr>
@@ -54446,7 +54412,7 @@
               <a:rPr sz="1000">
                 <a:latin typeface="Montserrat"/>
               </a:rPr>
-              <a:t>4 of 30 tickets use legal or regulatory escalation language - and these are exactly the tickets where an off-policy promise is most expensive to honour.</a:t>
+              <a:t>3 of 30 tickets use legal or regulatory escalation language - the Better Business Bureau, a state consumer protection office, and the FTC with an attorney engaged. These are exactly the tickets where an off-policy promise is most expensive to honour.</a:t>
             </a:r>
           </a:p>
           <a:p>
@@ -54460,7 +54426,21 @@
               <a:rPr sz="1000">
                 <a:latin typeface="Montserrat"/>
               </a:rPr>
-              <a:t>Emotional content is a large share of the words and almost none of the information. That is precisely what the summarisation stage removes, and why it saves real reading time.</a:t>
+              <a:t>The missing order reference is measurable in the scores, not just in principle. Replies to tickets that carry a reference average 5.65 of 6; replies to those without average 4.80. Same model, same prompt - the gap is the intake data.</a:t>
+            </a:r>
+          </a:p>
+          <a:p>
+            <a:pPr marL="203200" indent="-101600" algn="l">
+              <a:lnSpc>
+                <a:spcPts val="1360"/>
+              </a:lnSpc>
+              <a:buChar char="•"/>
+            </a:pPr>
+            <a:r>
+              <a:rPr sz="1000">
+                <a:latin typeface="Montserrat"/>
+              </a:rPr>
+              <a:t>Emotional content is a large share of the words and almost none of the information. The summariser compresses a mean of 80 words to 48, and the 184-word complaint to 60, with no loss of the order number, the model or the disputed amount.</a:t>
             </a:r>
           </a:p>
         </p:txBody>
@@ -54609,7 +54589,7 @@
               <a:rPr sz="1000">
                 <a:latin typeface="Montserrat"/>
               </a:rPr>
-              <a:t>Use the judge as a release gate: auto-send only where both criteria score 3 and no policy flag is raised. Everything else goes to a person. Widen the gate as evidence accumulates.</a:t>
+              <a:t>Use the judge as a release gate: auto-send only where both criteria score 3 and no policy flag is raised. On this run that gate passes 20 of 30 replies and routes the other 10 to a person - including the one the judge called unsafe. Widen it as evidence accumulates.</a:t>
             </a:r>
           </a:p>
           <a:p>
@@ -55772,6 +55752,34 @@
               <a:rPr sz="1150">
                 <a:latin typeface="Montserrat"/>
               </a:rPr>
+              <a:t>Result on the 30-ticket run: summaries scored 2.87 and 2.83 of 3; replies scored 5.37 of 6 overall, with 20 of 30 clean and zero invented identifiers anywhere in the output.</a:t>
+            </a:r>
+          </a:p>
+          <a:p>
+            <a:pPr marL="233680" indent="-116840" algn="l">
+              <a:lnSpc>
+                <a:spcPts val="1600"/>
+              </a:lnSpc>
+              <a:buChar char="•"/>
+            </a:pPr>
+            <a:r>
+              <a:rPr sz="1150">
+                <a:latin typeface="Montserrat"/>
+              </a:rPr>
+              <a:t>The judge already caught a real error. One reply misapplied a delivery policy to a case no policy covers, and was flagged 'not safe to send as written'. It was fluent, warm and wrong - which is precisely what human sampling misses.</a:t>
+            </a:r>
+          </a:p>
+          <a:p>
+            <a:pPr marL="233680" indent="-116840" algn="l">
+              <a:lnSpc>
+                <a:spcPts val="1600"/>
+              </a:lnSpc>
+              <a:buChar char="•"/>
+            </a:pPr>
+            <a:r>
+              <a:rPr sz="1150">
+                <a:latin typeface="Montserrat"/>
+              </a:rPr>
               <a:t>Ticket length runs from 3 words to 184 (mean 80). The cost is the variance, not the average: an agent must read all 184 to learn whether the one useful line is even there.</a:t>
             </a:r>
           </a:p>
@@ -57393,8 +57401,8 @@
         </p:nvSpPr>
         <p:spPr>
           <a:xfrm>
-            <a:off x="548640" y="1051560"/>
-            <a:ext cx="8092440" cy="3520440"/>
+            <a:off x="548640" y="3200400"/>
+            <a:ext cx="8092440" cy="1207008"/>
           </a:xfrm>
           <a:prstGeom prst="rect">
             <a:avLst/>
@@ -57410,57 +57418,14 @@
           </a:bodyPr>
           <a:lstStyle/>
           <a:p>
-            <a:pPr marL="0" lvl="0" indent="0" algn="l" rtl="0">
-              <a:buNone/>
-              <a:lnSpc>
-                <a:spcPts val="1700"/>
-              </a:lnSpc>
-              <a:spcBef>
-                <a:spcPts val="0"/>
-              </a:spcBef>
-              <a:spcAft>
-                <a:spcPts val="0"/>
-              </a:spcAft>
+            <a:pPr marL="0" indent="0">
+              <a:lnSpc>
+                <a:spcPts val="1100"/>
+              </a:lnSpc>
+              <a:buNone/>
             </a:pPr>
             <a:r>
-              <a:rPr b="1" sz="1200">
-                <a:solidFill>
-                  <a:srgbClr val="C00000"/>
-                </a:solidFill>
-                <a:latin typeface="Montserrat"/>
-              </a:rPr>
-              <a:t>[ SCREENSHOT: Summarization node - INPUT and OUTPUT panels ]</a:t>
-            </a:r>
-            <a:endParaRPr dirty="0">
-              <a:latin typeface="Montserrat"/>
-              <a:ea typeface="Montserrat"/>
-              <a:cs typeface="Montserrat"/>
-              <a:sym typeface="Montserrat"/>
-            </a:endParaRPr>
-          </a:p>
-          <a:p>
-            <a:pPr marL="0" indent="0">
-              <a:lnSpc>
-                <a:spcPts val="1400"/>
-              </a:lnSpc>
-              <a:buNone/>
-            </a:pPr>
-            <a:r>
-              <a:rPr i="1" sz="1000">
-                <a:latin typeface="Montserrat"/>
-              </a:rPr>
-              <a:t>Both panels open, 30 items visible in each, per the guidelines.</a:t>
-            </a:r>
-          </a:p>
-          <a:p>
-            <a:pPr marL="0" indent="0">
-              <a:lnSpc>
-                <a:spcPts val="1600"/>
-              </a:lnSpc>
-              <a:buNone/>
-            </a:pPr>
-            <a:r>
-              <a:rPr b="1" sz="1150">
+              <a:rPr b="1" sz="850">
                 <a:solidFill>
                   <a:srgbClr val="0E39A9"/>
                 </a:solidFill>
@@ -57472,33 +57437,71 @@
           <a:p>
             <a:pPr marL="203200" indent="-101600" algn="l">
               <a:lnSpc>
-                <a:spcPts val="1360"/>
+                <a:spcPts val="1100"/>
               </a:lnSpc>
               <a:buChar char="•"/>
             </a:pPr>
             <a:r>
-              <a:rPr sz="1000">
+              <a:rPr sz="850">
                 <a:latin typeface="Montserrat"/>
               </a:rPr>
-              <a:t>TO FILL FROM THE RUN: how the summariser handled the 184-word ticket, and whether it correctly refused to invent an order reference on the 10 tickets that lack one.</a:t>
+              <a:t>Compression is real and consistent. Tickets run 3 to 184 words (mean 80); the summaries run 27 to 66 words (mean 48). The 184-word complaint reduced to 60 words while keeping order SNX-5502, the exact model discrepancy and the $340 figure.</a:t>
             </a:r>
           </a:p>
           <a:p>
             <a:pPr marL="203200" indent="-101600" algn="l">
               <a:lnSpc>
-                <a:spcPts val="1360"/>
+                <a:spcPts val="1100"/>
               </a:lnSpc>
               <a:buChar char="•"/>
             </a:pPr>
             <a:r>
-              <a:rPr sz="1000">
+              <a:rPr sz="850">
                 <a:latin typeface="Montserrat"/>
               </a:rPr>
-              <a:t>TO FILL FROM THE RUN: behaviour on the three-word ticket - an honest short summary, or padding.</a:t>
+              <a:t>Zero invented identifiers across all 30 summaries. Every SNX- reference appearing in a summary also appears in its source ticket - checked programmatically, not by eye. On ticket 6, which cites two conflicting references, the summary preserved the ambiguity rather than silently picking one.</a:t>
+            </a:r>
+          </a:p>
+          <a:p>
+            <a:pPr marL="203200" indent="-101600" algn="l">
+              <a:lnSpc>
+                <a:spcPts val="1100"/>
+              </a:lnSpc>
+              <a:buChar char="•"/>
+            </a:pPr>
+            <a:r>
+              <a:rPr sz="850">
+                <a:latin typeface="Montserrat"/>
+              </a:rPr>
+              <a:t>The three-word ticket ('refund not received') produced an honest 28-word summary that states plainly that no order or transaction reference was provided. It did not pad, and it did not invent a reference to fill the gap.</a:t>
             </a:r>
           </a:p>
         </p:txBody>
       </p:sp>
+      <p:pic>
+        <p:nvPicPr>
+          <p:cNvPr id="336" name="Picture 335" descr="10_summarization.png"/>
+          <p:cNvPicPr>
+            <a:picLocks noChangeAspect="1"/>
+          </p:cNvPicPr>
+          <p:nvPr/>
+        </p:nvPicPr>
+        <p:blipFill>
+          <a:blip r:embed="rId2"/>
+          <a:stretch>
+            <a:fillRect/>
+          </a:stretch>
+        </p:blipFill>
+        <p:spPr>
+          <a:xfrm>
+            <a:off x="2179821" y="1051560"/>
+            <a:ext cx="4830078" cy="2057400"/>
+          </a:xfrm>
+          <a:prstGeom prst="rect">
+            <a:avLst/>
+          </a:prstGeom>
+        </p:spPr>
+      </p:pic>
     </p:spTree>
   </p:cSld>
   <p:clrMapOvr>

</xml_diff>

<commit_message>
Swap in the Table-view capture for Output & Compilation
The client re-sent Extract the Outputs, this time in Table view showing the
consolidated columns side by side. Better evidence for the compilation slide
than the Schema view it replaces.

Save the Data confirmed working: shopnest_ticket_output.csv is present in the
lab file store. The workflow now runs end to end and persists its result.

Co-Authored-By: Claude Opus 5 (1M context) <noreply@anthropic.com>
</commit_message>
<xml_diff>
--- a/deck/ShopNest_Solution_Presentation.pptx
+++ b/deck/ShopNest_Solution_Presentation.pptx
@@ -54218,8 +54218,8 @@
         </p:blipFill>
         <p:spPr>
           <a:xfrm>
-            <a:off x="2152023" y="1051560"/>
-            <a:ext cx="4885674" cy="2057400"/>
+            <a:off x="2095646" y="1051560"/>
+            <a:ext cx="4998427" cy="2057400"/>
           </a:xfrm>
           <a:prstGeom prst="rect">
             <a:avLst/>

</xml_diff>

<commit_message>
Deck complete: final screenshot placed, PDF exported
Extract Ticket Data capture placed on the Data Loading slide. It also shows the
Exclude BOM toggle on, so the byte-order-mark trap is now visible evidence
rather than just a claim in the notes - added a bullet explaining it.

Corrected a stale figure that survived on the data-profile slide: 3 tickets use
escalation language, not 4.

Swept the finished deck for stale text: no TO-FILL, no SCREENSHOT placeholders,
no 'mock' anywhere. 23 slides, 6 screenshots, exported to PDF.

Co-Authored-By: Claude Opus 5 (1M context) <noreply@anthropic.com>
</commit_message>
<xml_diff>
--- a/deck/ShopNest_Solution_Presentation.pptx
+++ b/deck/ShopNest_Solution_Presentation.pptx
@@ -56562,7 +56562,7 @@
               <a:rPr sz="950">
                 <a:latin typeface="Montserrat"/>
               </a:rPr>
-              <a:t>4 tickets contain legal or regulatory escalation language.</a:t>
+              <a:t>3 tickets contain legal or regulatory escalation language.</a:t>
             </a:r>
           </a:p>
         </p:txBody>
@@ -56860,8 +56860,8 @@
         </p:nvSpPr>
         <p:spPr>
           <a:xfrm>
-            <a:off x="548640" y="1051560"/>
-            <a:ext cx="8092440" cy="1705356"/>
+            <a:off x="548640" y="3200400"/>
+            <a:ext cx="8092440" cy="1207008"/>
           </a:xfrm>
           <a:prstGeom prst="rect">
             <a:avLst/>
@@ -56877,78 +56877,42 @@
           </a:bodyPr>
           <a:lstStyle/>
           <a:p>
-            <a:pPr marL="0" marR="0" lvl="0" indent="0" algn="l" rtl="0">
-              <a:buNone/>
-              <a:lnSpc>
-                <a:spcPts val="1700"/>
-              </a:lnSpc>
-              <a:spcBef>
-                <a:spcPts val="0"/>
-              </a:spcBef>
-              <a:spcAft>
-                <a:spcPts val="0"/>
-              </a:spcAft>
-              <a:buClr>
-                <a:srgbClr val="000000"/>
-              </a:buClr>
-              <a:buSzPts val="1400"/>
+            <a:pPr marL="213360" indent="-106680" algn="l">
+              <a:lnSpc>
+                <a:spcPts val="1100"/>
+              </a:lnSpc>
+              <a:buChar char="•"/>
             </a:pPr>
             <a:r>
-              <a:rPr b="1" sz="1200">
-                <a:solidFill>
-                  <a:srgbClr val="C00000"/>
-                </a:solidFill>
+              <a:rPr sz="850">
                 <a:latin typeface="Montserrat"/>
               </a:rPr>
-              <a:t>[ SCREENSHOT: Extract from File - output panel ]</a:t>
-            </a:r>
-            <a:endParaRPr sz="1400" b="0" i="0" u="none" strike="noStrike" cap="none">
-              <a:solidFill>
-                <a:srgbClr val="000000"/>
-              </a:solidFill>
-              <a:latin typeface="Montserrat"/>
-              <a:ea typeface="Montserrat"/>
-              <a:cs typeface="Montserrat"/>
-              <a:sym typeface="Montserrat"/>
-            </a:endParaRPr>
-          </a:p>
-          <a:p>
-            <a:pPr marL="0" indent="0">
-              <a:lnSpc>
-                <a:spcPts val="1400"/>
-              </a:lnSpc>
-              <a:buNone/>
-            </a:pPr>
-            <a:r>
-              <a:rPr i="1" sz="1000">
-                <a:latin typeface="Montserrat"/>
-              </a:rPr>
-              <a:t>Must show the item count (30 items) and at least one full row of data, per the guidelines.</a:t>
+              <a:t>30 items parsed from a 13.5 kB file, with both columns present and populated.</a:t>
             </a:r>
           </a:p>
           <a:p>
             <a:pPr marL="213360" indent="-106680" algn="l">
               <a:lnSpc>
-                <a:spcPts val="1400"/>
+                <a:spcPts val="1100"/>
               </a:lnSpc>
               <a:buChar char="•"/>
             </a:pPr>
             <a:r>
-              <a:rPr sz="1050">
+              <a:rPr sz="850">
                 <a:latin typeface="Montserrat"/>
               </a:rPr>
-              <a:t>Confirms 30 items parsed and both columns present.</a:t>
+              <a:t>Exclude Byte Order Mark is switched on deliberately. The source CSV begins with a UTF-8 byte order mark; left in, that mark becomes part of the first column's NAME, so support_ticket_id reads as empty and nothing anywhere raises an error.</a:t>
             </a:r>
           </a:p>
           <a:p>
             <a:pPr marL="213360" indent="-106680" algn="l">
               <a:lnSpc>
-                <a:spcPts val="1400"/>
+                <a:spcPts val="1100"/>
               </a:lnSpc>
               <a:buChar char="•"/>
             </a:pPr>
             <a:r>
-              <a:rPr sz="1050">
+              <a:rPr sz="850">
                 <a:latin typeface="Montserrat"/>
               </a:rPr>
               <a:t>The shortest ticket in the set, in full: "refund not received".</a:t>
@@ -57010,6 +56974,30 @@
           </a:p>
         </p:txBody>
       </p:sp>
+      <p:pic>
+        <p:nvPicPr>
+          <p:cNvPr id="327" name="Picture 326" descr="09_extract_ticket_data.png"/>
+          <p:cNvPicPr>
+            <a:picLocks noChangeAspect="1"/>
+          </p:cNvPicPr>
+          <p:nvPr/>
+        </p:nvPicPr>
+        <p:blipFill>
+          <a:blip r:embed="rId2"/>
+          <a:stretch>
+            <a:fillRect/>
+          </a:stretch>
+        </p:blipFill>
+        <p:spPr>
+          <a:xfrm>
+            <a:off x="2112647" y="1051560"/>
+            <a:ext cx="4964425" cy="2057400"/>
+          </a:xfrm>
+          <a:prstGeom prst="rect">
+            <a:avLst/>
+          </a:prstGeom>
+        </p:spPr>
+      </p:pic>
     </p:spTree>
   </p:cSld>
   <p:clrMapOvr>

</xml_diff>